<commit_message>
Update A-Share Blast Lab / manual
</commit_message>
<xml_diff>
--- a/assets/多空阶段简报_2026-10-27.pptx
+++ b/assets/多空阶段简报_2026-10-27.pptx
@@ -196,13 +196,13 @@
                   <c:v>0</c:v>
                 </c:pt>
                 <c:pt idx="1">
-                  <c:v>7</c:v>
+                  <c:v>8</c:v>
                 </c:pt>
                 <c:pt idx="2">
                   <c:v>1</c:v>
                 </c:pt>
                 <c:pt idx="3">
-                  <c:v>9</c:v>
+                  <c:v>8</c:v>
                 </c:pt>
               </c:numCache>
             </c:numRef>
@@ -340,19 +340,19 @@
                   <c:v>CPO</c:v>
                 </c:pt>
                 <c:pt idx="4">
+                  <c:v>电网设备</c:v>
+                </c:pt>
+                <c:pt idx="5">
                   <c:v>半导体设备</c:v>
                 </c:pt>
-                <c:pt idx="5">
-                  <c:v>存储</c:v>
-                </c:pt>
                 <c:pt idx="6">
-                  <c:v>电网设备</c:v>
+                  <c:v>半导体上游</c:v>
                 </c:pt>
                 <c:pt idx="7">
-                  <c:v>半导体上游</c:v>
+                  <c:v>MLCC</c:v>
                 </c:pt>
                 <c:pt idx="8">
-                  <c:v>MLCC</c:v>
+                  <c:v>存储</c:v>
                 </c:pt>
               </c:strCache>
             </c:strRef>
@@ -373,10 +373,10 @@
                   <c:v>0</c:v>
                 </c:pt>
                 <c:pt idx="3">
-                  <c:v>1</c:v>
+                  <c:v>2</c:v>
                 </c:pt>
                 <c:pt idx="4">
-                  <c:v>0</c:v>
+                  <c:v>1</c:v>
                 </c:pt>
                 <c:pt idx="5">
                   <c:v>0</c:v>
@@ -457,19 +457,19 @@
                   <c:v>CPO</c:v>
                 </c:pt>
                 <c:pt idx="4">
+                  <c:v>电网设备</c:v>
+                </c:pt>
+                <c:pt idx="5">
                   <c:v>半导体设备</c:v>
                 </c:pt>
-                <c:pt idx="5">
-                  <c:v>存储</c:v>
-                </c:pt>
                 <c:pt idx="6">
-                  <c:v>电网设备</c:v>
+                  <c:v>半导体上游</c:v>
                 </c:pt>
                 <c:pt idx="7">
-                  <c:v>半导体上游</c:v>
+                  <c:v>MLCC</c:v>
                 </c:pt>
                 <c:pt idx="8">
-                  <c:v>MLCC</c:v>
+                  <c:v>存储</c:v>
                 </c:pt>
               </c:strCache>
             </c:strRef>
@@ -493,13 +493,13 @@
                   <c:v>0</c:v>
                 </c:pt>
                 <c:pt idx="4">
-                  <c:v>0</c:v>
+                  <c:v>2</c:v>
                 </c:pt>
                 <c:pt idx="5">
                   <c:v>0</c:v>
                 </c:pt>
                 <c:pt idx="6">
-                  <c:v>1</c:v>
+                  <c:v>0</c:v>
                 </c:pt>
                 <c:pt idx="7">
                   <c:v>0</c:v>
@@ -551,19 +551,19 @@
                   <c:v>CPO</c:v>
                 </c:pt>
                 <c:pt idx="4">
+                  <c:v>电网设备</c:v>
+                </c:pt>
+                <c:pt idx="5">
                   <c:v>半导体设备</c:v>
                 </c:pt>
-                <c:pt idx="5">
-                  <c:v>存储</c:v>
-                </c:pt>
                 <c:pt idx="6">
-                  <c:v>电网设备</c:v>
+                  <c:v>半导体上游</c:v>
                 </c:pt>
                 <c:pt idx="7">
-                  <c:v>半导体上游</c:v>
+                  <c:v>MLCC</c:v>
                 </c:pt>
                 <c:pt idx="8">
-                  <c:v>MLCC</c:v>
+                  <c:v>存储</c:v>
                 </c:pt>
               </c:strCache>
             </c:strRef>
@@ -786,19 +786,19 @@
                   <c:v>CPO</c:v>
                 </c:pt>
                 <c:pt idx="4">
+                  <c:v>电网设备</c:v>
+                </c:pt>
+                <c:pt idx="5">
                   <c:v>半导体设备</c:v>
                 </c:pt>
-                <c:pt idx="5">
-                  <c:v>存储</c:v>
-                </c:pt>
                 <c:pt idx="6">
-                  <c:v>电网设备</c:v>
+                  <c:v>半导体上游</c:v>
                 </c:pt>
                 <c:pt idx="7">
-                  <c:v>半导体上游</c:v>
+                  <c:v>MLCC</c:v>
                 </c:pt>
                 <c:pt idx="8">
-                  <c:v>MLCC</c:v>
+                  <c:v>存储</c:v>
                 </c:pt>
               </c:strCache>
             </c:strRef>
@@ -819,22 +819,22 @@
                   <c:v>4.3</c:v>
                 </c:pt>
                 <c:pt idx="3">
-                  <c:v>0.0</c:v>
+                  <c:v>2.1</c:v>
                 </c:pt>
                 <c:pt idx="4">
-                  <c:v>0.0</c:v>
+                  <c:v>0.9</c:v>
                 </c:pt>
                 <c:pt idx="5">
                   <c:v>0.0</c:v>
                 </c:pt>
                 <c:pt idx="6">
-                  <c:v>-0.9</c:v>
+                  <c:v>0.0</c:v>
                 </c:pt>
                 <c:pt idx="7">
-                  <c:v>-2.0</c:v>
+                  <c:v>0.0</c:v>
                 </c:pt>
                 <c:pt idx="8">
-                  <c:v>-6.2</c:v>
+                  <c:v>0.0</c:v>
                 </c:pt>
               </c:numCache>
             </c:numRef>
@@ -1351,7 +1351,7 @@
           <a:lstStyle/>
           <a:p>
             <a:r>
-              <a:t>当日共 17 个分组；改善 7、恶化 9。转多力度第一为 互金证券，强度 6.67。最强低位转势候选为 黄金白银。</a:t>
+              <a:t>当日共 17 个分组；改善 8、恶化 8。转多力度第一为 互金证券，强度 6.67。最强低位转势候选为 黄金白银。</a:t>
             </a:r>
           </a:p>
         </p:txBody>
@@ -1561,7 +1561,7 @@
           <a:lstStyle/>
           <a:p>
             <a:r>
-              <a:t>次日先看空转多转多能否继续扩散，再检查空转空转多的蓄势池。反向压力主要来自：药 转空 29 只｜商业航天 转空 14 只｜AI应用 转空 13 只｜半导体芯片 转空 8 只。</a:t>
+              <a:t>次日先看空转多转多能否继续扩散，再检查空转空转多的蓄势池。反向压力主要来自：药 转空 31 只｜商业航天 转空 14 只｜AI应用 转空 14 只｜算力 转空 10 只。</a:t>
             </a:r>
           </a:p>
         </p:txBody>
@@ -4955,7 +4955,7 @@
                 </a:solidFill>
                 <a:latin typeface="Microsoft YaHei"/>
               </a:rPr>
-              <a:t>改善 7 · 恶化 9</a:t>
+              <a:t>改善 8 · 恶化 8</a:t>
             </a:r>
           </a:p>
         </p:txBody>
@@ -5794,7 +5794,7 @@
                 </a:solidFill>
                 <a:latin typeface="Microsoft YaHei"/>
               </a:rPr>
-              <a:t>互金证券转多确认最强，黄金白银以多占比 0.0% 成为最强低位转势候选，但同时提防药、商业航天等反向转空。</a:t>
+              <a:t>互金证券转多确认最强，黄金白银以多占比 0.0% 成为最强低位转势候选，但同时提防药、AI应用等反向转空。</a:t>
             </a:r>
           </a:p>
         </p:txBody>
@@ -6824,7 +6824,7 @@
                 </a:solidFill>
                 <a:latin typeface="Microsoft YaHei"/>
               </a:rPr>
-              <a:t>3 只｜多占比 26.8%</a:t>
+              <a:t>3 只｜多占比 25.4%</a:t>
             </a:r>
           </a:p>
         </p:txBody>
@@ -7905,7 +7905,7 @@
                         </a:defRPr>
                       </a:pPr>
                       <a:r>
-                        <a:t>0.0</a:t>
+                        <a:t>2.1</a:t>
                       </a:r>
                     </a:p>
                   </a:txBody>
@@ -7979,7 +7979,7 @@
                         </a:defRPr>
                       </a:pPr>
                       <a:r>
-                        <a:t>半导体设备</a:t>
+                        <a:t>电网设备</a:t>
                       </a:r>
                     </a:p>
                   </a:txBody>
@@ -8003,7 +8003,7 @@
                         </a:defRPr>
                       </a:pPr>
                       <a:r>
-                        <a:t>0.0</a:t>
+                        <a:t>0.9</a:t>
                       </a:r>
                     </a:p>
                   </a:txBody>
@@ -8027,7 +8027,7 @@
                         </a:defRPr>
                       </a:pPr>
                       <a:r>
-                        <a:t>0只</a:t>
+                        <a:t>2只</a:t>
                       </a:r>
                     </a:p>
                   </a:txBody>
@@ -8077,7 +8077,7 @@
                         </a:defRPr>
                       </a:pPr>
                       <a:r>
-                        <a:t>存储</a:t>
+                        <a:t>半导体设备</a:t>
                       </a:r>
                     </a:p>
                   </a:txBody>
@@ -9404,7 +9404,7 @@
                 </a:solidFill>
                 <a:latin typeface="Microsoft YaHei"/>
               </a:rPr>
-              <a:t>0.0 分</a:t>
+              <a:t>2.1 分</a:t>
             </a:r>
           </a:p>
         </p:txBody>
@@ -9446,7 +9446,7 @@
                 </a:solidFill>
                 <a:latin typeface="Microsoft YaHei"/>
               </a:rPr>
-              <a:t>空→空转多蓄势 1 只；反向转空 1 只</a:t>
+              <a:t>空→空转多蓄势 2 只；反向转空 1 只</a:t>
             </a:r>
           </a:p>
         </p:txBody>
@@ -9488,7 +9488,7 @@
                 </a:solidFill>
                 <a:latin typeface="Microsoft YaHei"/>
               </a:rPr>
-              <a:t>空转多→多 0 只｜空→空转多 1 只｜多占比 0.0%</a:t>
+              <a:t>空转多→多 0 只｜空→空转多 2 只｜多占比 0.0%</a:t>
             </a:r>
           </a:p>
         </p:txBody>
@@ -9555,7 +9555,7 @@
             <a:avLst/>
           </a:prstGeom>
           <a:solidFill>
-            <a:srgbClr val="F0B744"/>
+            <a:srgbClr val="E88B36"/>
           </a:solidFill>
           <a:ln>
             <a:noFill/>
@@ -9620,7 +9620,7 @@
                 </a:solidFill>
                 <a:latin typeface="Microsoft YaHei"/>
               </a:rPr>
-              <a:t>半导体设备</a:t>
+              <a:t>电网设备</a:t>
             </a:r>
           </a:p>
         </p:txBody>
@@ -9658,11 +9658,11 @@
             <a:r>
               <a:rPr sz="950" b="1" i="0">
                 <a:solidFill>
-                  <a:srgbClr val="F0B744"/>
+                  <a:srgbClr val="E88B36"/>
                 </a:solidFill>
                 <a:latin typeface="Microsoft YaHei"/>
               </a:rPr>
-              <a:t>0.0 分</a:t>
+              <a:t>0.9 分</a:t>
             </a:r>
           </a:p>
         </p:txBody>
@@ -9704,7 +9704,7 @@
                 </a:solidFill>
                 <a:latin typeface="Microsoft YaHei"/>
               </a:rPr>
-              <a:t>转空抬头</a:t>
+              <a:t>空转多→多 1→2；反向转空 4 只</a:t>
             </a:r>
           </a:p>
         </p:txBody>
@@ -9746,7 +9746,7 @@
                 </a:solidFill>
                 <a:latin typeface="Microsoft YaHei"/>
               </a:rPr>
-              <a:t>空转多→多 0 只｜空→空转多 0 只｜多占比 0.0%</a:t>
+              <a:t>空转多→多 2 只｜空→空转多 1 只｜多占比 19.6%</a:t>
             </a:r>
           </a:p>
         </p:txBody>
@@ -9878,7 +9878,7 @@
                 </a:solidFill>
                 <a:latin typeface="Microsoft YaHei"/>
               </a:rPr>
-              <a:t>存储</a:t>
+              <a:t>半导体设备</a:t>
             </a:r>
           </a:p>
         </p:txBody>
@@ -9962,7 +9962,7 @@
                 </a:solidFill>
                 <a:latin typeface="Microsoft YaHei"/>
               </a:rPr>
-              <a:t>变化有限</a:t>
+              <a:t>转空抬头</a:t>
             </a:r>
           </a:p>
         </p:txBody>
@@ -10004,7 +10004,7 @@
                 </a:solidFill>
                 <a:latin typeface="Microsoft YaHei"/>
               </a:rPr>
-              <a:t>空转多→多 0 只｜空→空转多 0 只｜多占比 27.3%</a:t>
+              <a:t>空转多→多 0 只｜空→空转多 0 只｜多占比 0.0%</a:t>
             </a:r>
           </a:p>
         </p:txBody>
@@ -10133,7 +10133,7 @@
                 </a:solidFill>
                 <a:latin typeface="Microsoft YaHei"/>
               </a:rPr>
-              <a:t>药 转空 29 只｜商业航天 转空 14 只｜AI应用 转空 13 只｜半导体芯片 转空 8 只</a:t>
+              <a:t>药 转空 31 只｜商业航天 转空 14 只｜AI应用 转空 14 只｜算力 转空 10 只</a:t>
             </a:r>
           </a:p>
         </p:txBody>

</xml_diff>

<commit_message>
Update A-Share Blast Lab / 2026-10-27 close-update-retry2
</commit_message>
<xml_diff>
--- a/assets/多空阶段简报_2026-10-27.pptx
+++ b/assets/多空阶段简报_2026-10-27.pptx
@@ -196,13 +196,13 @@
                   <c:v>0</c:v>
                 </c:pt>
                 <c:pt idx="1">
-                  <c:v>8</c:v>
+                  <c:v>2</c:v>
                 </c:pt>
                 <c:pt idx="2">
                   <c:v>1</c:v>
                 </c:pt>
                 <c:pt idx="3">
-                  <c:v>8</c:v>
+                  <c:v>14</c:v>
                 </c:pt>
               </c:numCache>
             </c:numRef>
@@ -328,31 +328,31 @@
               <c:strCache>
                 <c:ptCount val="9"/>
                 <c:pt idx="0">
-                  <c:v>互金证券</c:v>
+                  <c:v>存储</c:v>
                 </c:pt>
                 <c:pt idx="1">
                   <c:v>黄金白银</c:v>
                 </c:pt>
                 <c:pt idx="2">
-                  <c:v>机器人</c:v>
+                  <c:v>电网设备</c:v>
                 </c:pt>
                 <c:pt idx="3">
+                  <c:v>半导体设备</c:v>
+                </c:pt>
+                <c:pt idx="4">
                   <c:v>CPO</c:v>
                 </c:pt>
-                <c:pt idx="4">
-                  <c:v>电网设备</c:v>
-                </c:pt>
                 <c:pt idx="5">
-                  <c:v>半导体设备</c:v>
+                  <c:v>光上游</c:v>
                 </c:pt>
                 <c:pt idx="6">
                   <c:v>半导体上游</c:v>
                 </c:pt>
                 <c:pt idx="7">
-                  <c:v>MLCC</c:v>
+                  <c:v>PCB</c:v>
                 </c:pt>
                 <c:pt idx="8">
-                  <c:v>存储</c:v>
+                  <c:v>机器人</c:v>
                 </c:pt>
               </c:strCache>
             </c:strRef>
@@ -364,28 +364,28 @@
                 <c:formatCode>General</c:formatCode>
                 <c:ptCount val="9"/>
                 <c:pt idx="0">
-                  <c:v>7</c:v>
+                  <c:v>0</c:v>
                 </c:pt>
                 <c:pt idx="1">
-                  <c:v>1</c:v>
+                  <c:v>0</c:v>
                 </c:pt>
                 <c:pt idx="2">
+                  <c:v>2</c:v>
+                </c:pt>
+                <c:pt idx="3">
                   <c:v>0</c:v>
                 </c:pt>
-                <c:pt idx="3">
-                  <c:v>2</c:v>
-                </c:pt>
                 <c:pt idx="4">
-                  <c:v>1</c:v>
+                  <c:v>0</c:v>
                 </c:pt>
                 <c:pt idx="5">
                   <c:v>0</c:v>
                 </c:pt>
                 <c:pt idx="6">
-                  <c:v>1</c:v>
+                  <c:v>0</c:v>
                 </c:pt>
                 <c:pt idx="7">
-                  <c:v>1</c:v>
+                  <c:v>0</c:v>
                 </c:pt>
                 <c:pt idx="8">
                   <c:v>0</c:v>
@@ -445,31 +445,31 @@
               <c:strCache>
                 <c:ptCount val="9"/>
                 <c:pt idx="0">
-                  <c:v>互金证券</c:v>
+                  <c:v>存储</c:v>
                 </c:pt>
                 <c:pt idx="1">
                   <c:v>黄金白银</c:v>
                 </c:pt>
                 <c:pt idx="2">
-                  <c:v>机器人</c:v>
+                  <c:v>电网设备</c:v>
                 </c:pt>
                 <c:pt idx="3">
+                  <c:v>半导体设备</c:v>
+                </c:pt>
+                <c:pt idx="4">
                   <c:v>CPO</c:v>
                 </c:pt>
-                <c:pt idx="4">
-                  <c:v>电网设备</c:v>
-                </c:pt>
                 <c:pt idx="5">
-                  <c:v>半导体设备</c:v>
+                  <c:v>光上游</c:v>
                 </c:pt>
                 <c:pt idx="6">
                   <c:v>半导体上游</c:v>
                 </c:pt>
                 <c:pt idx="7">
-                  <c:v>MLCC</c:v>
+                  <c:v>PCB</c:v>
                 </c:pt>
                 <c:pt idx="8">
-                  <c:v>存储</c:v>
+                  <c:v>机器人</c:v>
                 </c:pt>
               </c:strCache>
             </c:strRef>
@@ -481,7 +481,7 @@
                 <c:formatCode>General</c:formatCode>
                 <c:ptCount val="9"/>
                 <c:pt idx="0">
-                  <c:v>1</c:v>
+                  <c:v>0</c:v>
                 </c:pt>
                 <c:pt idx="1">
                   <c:v>0</c:v>
@@ -490,10 +490,10 @@
                   <c:v>2</c:v>
                 </c:pt>
                 <c:pt idx="3">
-                  <c:v>0</c:v>
+                  <c:v>1</c:v>
                 </c:pt>
                 <c:pt idx="4">
-                  <c:v>2</c:v>
+                  <c:v>0</c:v>
                 </c:pt>
                 <c:pt idx="5">
                   <c:v>0</c:v>
@@ -505,7 +505,7 @@
                   <c:v>0</c:v>
                 </c:pt>
                 <c:pt idx="8">
-                  <c:v>0</c:v>
+                  <c:v>2</c:v>
                 </c:pt>
               </c:numCache>
             </c:numRef>
@@ -539,31 +539,31 @@
               <c:strCache>
                 <c:ptCount val="9"/>
                 <c:pt idx="0">
-                  <c:v>互金证券</c:v>
+                  <c:v>存储</c:v>
                 </c:pt>
                 <c:pt idx="1">
                   <c:v>黄金白银</c:v>
                 </c:pt>
                 <c:pt idx="2">
-                  <c:v>机器人</c:v>
+                  <c:v>电网设备</c:v>
                 </c:pt>
                 <c:pt idx="3">
+                  <c:v>半导体设备</c:v>
+                </c:pt>
+                <c:pt idx="4">
                   <c:v>CPO</c:v>
                 </c:pt>
-                <c:pt idx="4">
-                  <c:v>电网设备</c:v>
-                </c:pt>
                 <c:pt idx="5">
-                  <c:v>半导体设备</c:v>
+                  <c:v>光上游</c:v>
                 </c:pt>
                 <c:pt idx="6">
                   <c:v>半导体上游</c:v>
                 </c:pt>
                 <c:pt idx="7">
-                  <c:v>MLCC</c:v>
+                  <c:v>PCB</c:v>
                 </c:pt>
                 <c:pt idx="8">
-                  <c:v>存储</c:v>
+                  <c:v>机器人</c:v>
                 </c:pt>
               </c:strCache>
             </c:strRef>
@@ -774,31 +774,31 @@
               <c:strCache>
                 <c:ptCount val="9"/>
                 <c:pt idx="0">
-                  <c:v>互金证券</c:v>
+                  <c:v>存储</c:v>
                 </c:pt>
                 <c:pt idx="1">
                   <c:v>黄金白银</c:v>
                 </c:pt>
                 <c:pt idx="2">
-                  <c:v>机器人</c:v>
+                  <c:v>电网设备</c:v>
                 </c:pt>
                 <c:pt idx="3">
+                  <c:v>半导体设备</c:v>
+                </c:pt>
+                <c:pt idx="4">
                   <c:v>CPO</c:v>
                 </c:pt>
-                <c:pt idx="4">
-                  <c:v>电网设备</c:v>
-                </c:pt>
                 <c:pt idx="5">
-                  <c:v>半导体设备</c:v>
+                  <c:v>光上游</c:v>
                 </c:pt>
                 <c:pt idx="6">
                   <c:v>半导体上游</c:v>
                 </c:pt>
                 <c:pt idx="7">
-                  <c:v>MLCC</c:v>
+                  <c:v>PCB</c:v>
                 </c:pt>
                 <c:pt idx="8">
-                  <c:v>存储</c:v>
+                  <c:v>机器人</c:v>
                 </c:pt>
               </c:strCache>
             </c:strRef>
@@ -810,31 +810,31 @@
                 <c:formatCode>General</c:formatCode>
                 <c:ptCount val="9"/>
                 <c:pt idx="0">
-                  <c:v>6.7</c:v>
+                  <c:v>0.0</c:v>
                 </c:pt>
                 <c:pt idx="1">
-                  <c:v>4.5</c:v>
+                  <c:v>0.0</c:v>
                 </c:pt>
                 <c:pt idx="2">
-                  <c:v>4.3</c:v>
+                  <c:v>-2.7</c:v>
                 </c:pt>
                 <c:pt idx="3">
-                  <c:v>2.1</c:v>
+                  <c:v>-3.3</c:v>
                 </c:pt>
                 <c:pt idx="4">
-                  <c:v>0.9</c:v>
+                  <c:v>-4.1</c:v>
                 </c:pt>
                 <c:pt idx="5">
-                  <c:v>0.0</c:v>
+                  <c:v>-5.1</c:v>
                 </c:pt>
                 <c:pt idx="6">
-                  <c:v>0.0</c:v>
+                  <c:v>-6.1</c:v>
                 </c:pt>
                 <c:pt idx="7">
-                  <c:v>0.0</c:v>
+                  <c:v>-7.9</c:v>
                 </c:pt>
                 <c:pt idx="8">
-                  <c:v>0.0</c:v>
+                  <c:v>-8.6</c:v>
                 </c:pt>
               </c:numCache>
             </c:numRef>
@@ -1351,7 +1351,7 @@
           <a:lstStyle/>
           <a:p>
             <a:r>
-              <a:t>当日共 17 个分组；改善 8、恶化 8。转多力度第一为 互金证券，强度 6.67。最强低位转势候选为 黄金白银。</a:t>
+              <a:t>当日共 17 个分组；改善 2、恶化 14。转多力度第一为 存储，强度 0.00。最强低位转势候选为 无。</a:t>
             </a:r>
           </a:p>
         </p:txBody>
@@ -1421,7 +1421,7 @@
           <a:lstStyle/>
           <a:p>
             <a:r>
-              <a:t>堆叠柱分别代表空转空转多、空转多转多、空直接转多。后两者更接近真实转多确认，空转空转多则是下一轮候选。最强低位转势候选：黄金白银。</a:t>
+              <a:t>堆叠柱分别代表空转空转多、空转多转多、空直接转多。后两者更接近真实转多确认，空转空转多则是下一轮候选。最强低位转势候选：无。</a:t>
             </a:r>
           </a:p>
         </p:txBody>
@@ -1561,7 +1561,7 @@
           <a:lstStyle/>
           <a:p>
             <a:r>
-              <a:t>次日先看空转多转多能否继续扩散，再检查空转空转多的蓄势池。反向压力主要来自：药 转空 31 只｜商业航天 转空 14 只｜AI应用 转空 14 只｜算力 转空 10 只。</a:t>
+              <a:t>次日先看空转多转多能否继续扩散，再检查空转空转多的蓄势池。反向压力主要来自：药 转空 38 只｜AI应用 转空 28 只｜商业航天 转空 25 只｜算力 转空 19 只。</a:t>
             </a:r>
           </a:p>
         </p:txBody>
@@ -4955,7 +4955,7 @@
                 </a:solidFill>
                 <a:latin typeface="Microsoft YaHei"/>
               </a:rPr>
-              <a:t>改善 8 · 恶化 8</a:t>
+              <a:t>改善 2 · 恶化 14</a:t>
             </a:r>
           </a:p>
         </p:txBody>
@@ -5345,7 +5345,7 @@
                 </a:solidFill>
                 <a:latin typeface="Microsoft YaHei"/>
               </a:rPr>
-              <a:t>4</a:t>
+              <a:t>7</a:t>
             </a:r>
           </a:p>
         </p:txBody>
@@ -5561,7 +5561,7 @@
                 </a:solidFill>
                 <a:latin typeface="Microsoft YaHei"/>
               </a:rPr>
-              <a:t>互金证券</a:t>
+              <a:t>存储</a:t>
             </a:r>
           </a:p>
         </p:txBody>
@@ -5603,7 +5603,7 @@
                 </a:solidFill>
                 <a:latin typeface="Microsoft YaHei"/>
               </a:rPr>
-              <a:t>强度 6.7</a:t>
+              <a:t>强度 0.0</a:t>
             </a:r>
           </a:p>
         </p:txBody>
@@ -5794,7 +5794,7 @@
                 </a:solidFill>
                 <a:latin typeface="Microsoft YaHei"/>
               </a:rPr>
-              <a:t>互金证券转多确认最强，黄金白银以多占比 0.0% 成为最强低位转势候选，但同时提防药、AI应用等反向转空。</a:t>
+              <a:t>存储转多确认最强，当前没有满足低位条件的转势候选，但同时提防药、AI应用等反向转空。</a:t>
             </a:r>
           </a:p>
         </p:txBody>
@@ -5923,7 +5923,7 @@
                 </a:solidFill>
                 <a:latin typeface="Microsoft YaHei"/>
               </a:rPr>
-              <a:t>黄金白银</a:t>
+              <a:t>暂无</a:t>
             </a:r>
           </a:p>
         </p:txBody>
@@ -6052,7 +6052,7 @@
                 </a:solidFill>
                 <a:latin typeface="Microsoft YaHei"/>
               </a:rPr>
-              <a:t>1 只</a:t>
+              <a:t>0 只</a:t>
             </a:r>
           </a:p>
         </p:txBody>
@@ -6181,7 +6181,7 @@
                 </a:solidFill>
                 <a:latin typeface="Microsoft YaHei"/>
               </a:rPr>
-              <a:t>4 个</a:t>
+              <a:t>7 个</a:t>
             </a:r>
           </a:p>
         </p:txBody>
@@ -6609,7 +6609,7 @@
                 </a:solidFill>
                 <a:latin typeface="Microsoft YaHei"/>
               </a:rPr>
-              <a:t>互金证券</a:t>
+              <a:t>存储</a:t>
             </a:r>
           </a:p>
         </p:txBody>
@@ -6651,7 +6651,7 @@
                 </a:solidFill>
                 <a:latin typeface="Microsoft YaHei"/>
               </a:rPr>
-              <a:t>空转多→多 1→1 只</a:t>
+              <a:t>空转多→多 0→0 只</a:t>
             </a:r>
           </a:p>
         </p:txBody>
@@ -6824,7 +6824,7 @@
                 </a:solidFill>
                 <a:latin typeface="Microsoft YaHei"/>
               </a:rPr>
-              <a:t>3 只｜多占比 25.4%</a:t>
+              <a:t>2 只｜多占比 15.5%</a:t>
             </a:r>
           </a:p>
         </p:txBody>
@@ -6953,7 +6953,7 @@
                 </a:solidFill>
                 <a:latin typeface="Microsoft YaHei"/>
               </a:rPr>
-              <a:t>黄金白银</a:t>
+              <a:t>暂无</a:t>
             </a:r>
           </a:p>
         </p:txBody>
@@ -6995,7 +6995,7 @@
                 </a:solidFill>
                 <a:latin typeface="Microsoft YaHei"/>
               </a:rPr>
-              <a:t>多占比 0.0%｜空转多→多 0 只｜空→空转多 1 只</a:t>
+              <a:t>没有同时满足低位与转势条件的组</a:t>
             </a:r>
           </a:p>
         </p:txBody>
@@ -7421,7 +7421,7 @@
                 </a:solidFill>
                 <a:latin typeface="Microsoft YaHei"/>
               </a:rPr>
-              <a:t>互金证券  ·  6.7</a:t>
+              <a:t>存储  ·  0.0</a:t>
             </a:r>
           </a:p>
         </p:txBody>
@@ -7587,7 +7587,7 @@
                         </a:defRPr>
                       </a:pPr>
                       <a:r>
-                        <a:t>互金证券</a:t>
+                        <a:t>存储</a:t>
                       </a:r>
                     </a:p>
                   </a:txBody>
@@ -7611,7 +7611,7 @@
                         </a:defRPr>
                       </a:pPr>
                       <a:r>
-                        <a:t>6.7</a:t>
+                        <a:t>0.0</a:t>
                       </a:r>
                     </a:p>
                   </a:txBody>
@@ -7635,7 +7635,7 @@
                         </a:defRPr>
                       </a:pPr>
                       <a:r>
-                        <a:t>1只</a:t>
+                        <a:t>0只</a:t>
                       </a:r>
                     </a:p>
                   </a:txBody>
@@ -7709,7 +7709,7 @@
                         </a:defRPr>
                       </a:pPr>
                       <a:r>
-                        <a:t>4.5</a:t>
+                        <a:t>0.0</a:t>
                       </a:r>
                     </a:p>
                   </a:txBody>
@@ -7783,7 +7783,7 @@
                         </a:defRPr>
                       </a:pPr>
                       <a:r>
-                        <a:t>机器人</a:t>
+                        <a:t>电网设备</a:t>
                       </a:r>
                     </a:p>
                   </a:txBody>
@@ -7807,7 +7807,7 @@
                         </a:defRPr>
                       </a:pPr>
                       <a:r>
-                        <a:t>4.3</a:t>
+                        <a:t>-2.7</a:t>
                       </a:r>
                     </a:p>
                   </a:txBody>
@@ -7881,7 +7881,7 @@
                         </a:defRPr>
                       </a:pPr>
                       <a:r>
-                        <a:t>CPO</a:t>
+                        <a:t>半导体设备</a:t>
                       </a:r>
                     </a:p>
                   </a:txBody>
@@ -7905,7 +7905,7 @@
                         </a:defRPr>
                       </a:pPr>
                       <a:r>
-                        <a:t>2.1</a:t>
+                        <a:t>-3.3</a:t>
                       </a:r>
                     </a:p>
                   </a:txBody>
@@ -7929,7 +7929,7 @@
                         </a:defRPr>
                       </a:pPr>
                       <a:r>
-                        <a:t>0只</a:t>
+                        <a:t>1只</a:t>
                       </a:r>
                     </a:p>
                   </a:txBody>
@@ -7979,7 +7979,7 @@
                         </a:defRPr>
                       </a:pPr>
                       <a:r>
-                        <a:t>电网设备</a:t>
+                        <a:t>CPO</a:t>
                       </a:r>
                     </a:p>
                   </a:txBody>
@@ -8003,7 +8003,7 @@
                         </a:defRPr>
                       </a:pPr>
                       <a:r>
-                        <a:t>0.9</a:t>
+                        <a:t>-4.1</a:t>
                       </a:r>
                     </a:p>
                   </a:txBody>
@@ -8027,7 +8027,7 @@
                         </a:defRPr>
                       </a:pPr>
                       <a:r>
-                        <a:t>2只</a:t>
+                        <a:t>0只</a:t>
                       </a:r>
                     </a:p>
                   </a:txBody>
@@ -8077,7 +8077,7 @@
                         </a:defRPr>
                       </a:pPr>
                       <a:r>
-                        <a:t>半导体设备</a:t>
+                        <a:t>光上游</a:t>
                       </a:r>
                     </a:p>
                   </a:txBody>
@@ -8101,7 +8101,7 @@
                         </a:defRPr>
                       </a:pPr>
                       <a:r>
-                        <a:t>0.0</a:t>
+                        <a:t>-5.1</a:t>
                       </a:r>
                     </a:p>
                   </a:txBody>
@@ -8523,7 +8523,7 @@
             <a:avLst/>
           </a:prstGeom>
           <a:solidFill>
-            <a:srgbClr val="E88B36"/>
+            <a:srgbClr val="F0B744"/>
           </a:solidFill>
           <a:ln>
             <a:noFill/>
@@ -8588,7 +8588,7 @@
                 </a:solidFill>
                 <a:latin typeface="Microsoft YaHei"/>
               </a:rPr>
-              <a:t>互金证券</a:t>
+              <a:t>存储</a:t>
             </a:r>
           </a:p>
         </p:txBody>
@@ -8626,11 +8626,11 @@
             <a:r>
               <a:rPr sz="950" b="1" i="0">
                 <a:solidFill>
-                  <a:srgbClr val="E88B36"/>
+                  <a:srgbClr val="F0B744"/>
                 </a:solidFill>
                 <a:latin typeface="Microsoft YaHei"/>
               </a:rPr>
-              <a:t>6.7 分</a:t>
+              <a:t>0.0 分</a:t>
             </a:r>
           </a:p>
         </p:txBody>
@@ -8672,7 +8672,7 @@
                 </a:solidFill>
                 <a:latin typeface="Microsoft YaHei"/>
               </a:rPr>
-              <a:t>空转多→多 1→1；反向转空 5 只</a:t>
+              <a:t>修复延续</a:t>
             </a:r>
           </a:p>
         </p:txBody>
@@ -8714,7 +8714,7 @@
                 </a:solidFill>
                 <a:latin typeface="Microsoft YaHei"/>
               </a:rPr>
-              <a:t>空转多→多 1 只｜空→空转多 7 只｜多占比 6.7%</a:t>
+              <a:t>空转多→多 0 只｜空→空转多 0 只｜多占比 18.2%</a:t>
             </a:r>
           </a:p>
         </p:txBody>
@@ -8888,7 +8888,7 @@
                 </a:solidFill>
                 <a:latin typeface="Microsoft YaHei"/>
               </a:rPr>
-              <a:t>4.5 分</a:t>
+              <a:t>0.0 分</a:t>
             </a:r>
           </a:p>
         </p:txBody>
@@ -8930,7 +8930,7 @@
                 </a:solidFill>
                 <a:latin typeface="Microsoft YaHei"/>
               </a:rPr>
-              <a:t>空→空转多蓄势 1 只</a:t>
+              <a:t>变化有限</a:t>
             </a:r>
           </a:p>
         </p:txBody>
@@ -8972,7 +8972,7 @@
                 </a:solidFill>
                 <a:latin typeface="Microsoft YaHei"/>
               </a:rPr>
-              <a:t>空转多→多 0 只｜空→空转多 1 只｜多占比 0.0%</a:t>
+              <a:t>空转多→多 0 只｜空→空转多 0 只｜多占比 0.0%</a:t>
             </a:r>
           </a:p>
         </p:txBody>
@@ -9104,7 +9104,7 @@
                 </a:solidFill>
                 <a:latin typeface="Microsoft YaHei"/>
               </a:rPr>
-              <a:t>机器人</a:t>
+              <a:t>电网设备</a:t>
             </a:r>
           </a:p>
         </p:txBody>
@@ -9146,7 +9146,7 @@
                 </a:solidFill>
                 <a:latin typeface="Microsoft YaHei"/>
               </a:rPr>
-              <a:t>4.3 分</a:t>
+              <a:t>-2.7 分</a:t>
             </a:r>
           </a:p>
         </p:txBody>
@@ -9188,7 +9188,7 @@
                 </a:solidFill>
                 <a:latin typeface="Microsoft YaHei"/>
               </a:rPr>
-              <a:t>空转多→多 5→2；反向转空 1 只</a:t>
+              <a:t>空转多→多 1→2；反向转空 6 只</a:t>
             </a:r>
           </a:p>
         </p:txBody>
@@ -9230,7 +9230,7 @@
                 </a:solidFill>
                 <a:latin typeface="Microsoft YaHei"/>
               </a:rPr>
-              <a:t>空转多→多 2 只｜空→空转多 0 只｜多占比 77.1%</a:t>
+              <a:t>空转多→多 2 只｜空→空转多 2 只｜多占比 16.1%</a:t>
             </a:r>
           </a:p>
         </p:txBody>
@@ -9297,7 +9297,7 @@
             <a:avLst/>
           </a:prstGeom>
           <a:solidFill>
-            <a:srgbClr val="F0B744"/>
+            <a:srgbClr val="E88B36"/>
           </a:solidFill>
           <a:ln>
             <a:noFill/>
@@ -9362,7 +9362,7 @@
                 </a:solidFill>
                 <a:latin typeface="Microsoft YaHei"/>
               </a:rPr>
-              <a:t>CPO</a:t>
+              <a:t>半导体设备</a:t>
             </a:r>
           </a:p>
         </p:txBody>
@@ -9400,11 +9400,11 @@
             <a:r>
               <a:rPr sz="950" b="1" i="0">
                 <a:solidFill>
-                  <a:srgbClr val="F0B744"/>
+                  <a:srgbClr val="E88B36"/>
                 </a:solidFill>
                 <a:latin typeface="Microsoft YaHei"/>
               </a:rPr>
-              <a:t>2.1 分</a:t>
+              <a:t>-3.3 分</a:t>
             </a:r>
           </a:p>
         </p:txBody>
@@ -9446,7 +9446,7 @@
                 </a:solidFill>
                 <a:latin typeface="Microsoft YaHei"/>
               </a:rPr>
-              <a:t>空→空转多蓄势 2 只；反向转空 1 只</a:t>
+              <a:t>空转多→多 0→1；反向转空 3 只</a:t>
             </a:r>
           </a:p>
         </p:txBody>
@@ -9488,7 +9488,7 @@
                 </a:solidFill>
                 <a:latin typeface="Microsoft YaHei"/>
               </a:rPr>
-              <a:t>空转多→多 0 只｜空→空转多 2 只｜多占比 0.0%</a:t>
+              <a:t>空转多→多 1 只｜空→空转多 0 只｜多占比 2.2%</a:t>
             </a:r>
           </a:p>
         </p:txBody>
@@ -9555,7 +9555,7 @@
             <a:avLst/>
           </a:prstGeom>
           <a:solidFill>
-            <a:srgbClr val="E88B36"/>
+            <a:srgbClr val="F0B744"/>
           </a:solidFill>
           <a:ln>
             <a:noFill/>
@@ -9620,7 +9620,7 @@
                 </a:solidFill>
                 <a:latin typeface="Microsoft YaHei"/>
               </a:rPr>
-              <a:t>电网设备</a:t>
+              <a:t>CPO</a:t>
             </a:r>
           </a:p>
         </p:txBody>
@@ -9658,11 +9658,11 @@
             <a:r>
               <a:rPr sz="950" b="1" i="0">
                 <a:solidFill>
-                  <a:srgbClr val="E88B36"/>
+                  <a:srgbClr val="F0B744"/>
                 </a:solidFill>
                 <a:latin typeface="Microsoft YaHei"/>
               </a:rPr>
-              <a:t>0.9 分</a:t>
+              <a:t>-4.1 分</a:t>
             </a:r>
           </a:p>
         </p:txBody>
@@ -9704,7 +9704,7 @@
                 </a:solidFill>
                 <a:latin typeface="Microsoft YaHei"/>
               </a:rPr>
-              <a:t>空转多→多 1→2；反向转空 4 只</a:t>
+              <a:t>反向转空 2 只</a:t>
             </a:r>
           </a:p>
         </p:txBody>
@@ -9746,7 +9746,7 @@
                 </a:solidFill>
                 <a:latin typeface="Microsoft YaHei"/>
               </a:rPr>
-              <a:t>空转多→多 2 只｜空→空转多 1 只｜多占比 19.6%</a:t>
+              <a:t>空转多→多 0 只｜空→空转多 0 只｜多占比 0.0%</a:t>
             </a:r>
           </a:p>
         </p:txBody>
@@ -9878,7 +9878,7 @@
                 </a:solidFill>
                 <a:latin typeface="Microsoft YaHei"/>
               </a:rPr>
-              <a:t>半导体设备</a:t>
+              <a:t>光上游</a:t>
             </a:r>
           </a:p>
         </p:txBody>
@@ -9920,7 +9920,7 @@
                 </a:solidFill>
                 <a:latin typeface="Microsoft YaHei"/>
               </a:rPr>
-              <a:t>0.0 分</a:t>
+              <a:t>-5.1 分</a:t>
             </a:r>
           </a:p>
         </p:txBody>
@@ -9962,7 +9962,7 @@
                 </a:solidFill>
                 <a:latin typeface="Microsoft YaHei"/>
               </a:rPr>
-              <a:t>转空抬头</a:t>
+              <a:t>反向转空 2 只</a:t>
             </a:r>
           </a:p>
         </p:txBody>
@@ -10004,7 +10004,7 @@
                 </a:solidFill>
                 <a:latin typeface="Microsoft YaHei"/>
               </a:rPr>
-              <a:t>空转多→多 0 只｜空→空转多 0 只｜多占比 0.0%</a:t>
+              <a:t>空转多→多 0 只｜空→空转多 0 只｜多占比 5.1%</a:t>
             </a:r>
           </a:p>
         </p:txBody>
@@ -10133,7 +10133,7 @@
                 </a:solidFill>
                 <a:latin typeface="Microsoft YaHei"/>
               </a:rPr>
-              <a:t>药 转空 31 只｜商业航天 转空 14 只｜AI应用 转空 14 只｜算力 转空 10 只</a:t>
+              <a:t>药 转空 38 只｜AI应用 转空 28 只｜商业航天 转空 25 只｜算力 转空 19 只</a:t>
             </a:r>
           </a:p>
         </p:txBody>

</xml_diff>